<commit_message>
Show data and method limitations instead of next steps
</commit_message>
<xml_diff>
--- a/presentation/Bitcoin_Forensics_Project_Review.pptx
+++ b/presentation/Bitcoin_Forensics_Project_Review.pptx
@@ -1728,7 +1728,7 @@
           <a:p>
             <a:r>
               <a:rPr lang="en-US" dirty="0"/>
-              <a:t>Be direct about limits. The next experiment that matters most is Random Forest on feature set B with the same split.</a:t>
+              <a:t>These limits come mostly from the dataset and cannot be removed by more modelling. A flagged transaction is a reason to investigate, never a finding.</a:t>
             </a:r>
             <a:endParaRPr lang="en-US" dirty="0"/>
           </a:p>
@@ -6740,7 +6740,7 @@
                   <a:srgbClr val="1A1A1A"/>
                 </a:solidFill>
               </a:rPr>
-              <a:t>What this does not show, and what comes next</a:t>
+              <a:t>What the data and the method cannot show</a:t>
             </a:r>
             <a:endParaRPr lang="en-US" sz="3000" dirty="0"/>
           </a:p>
@@ -6755,7 +6755,7 @@
         <p:spPr>
           <a:xfrm>
             <a:off x="548640" y="1371600"/>
-            <a:ext cx="5303520" cy="365760"/>
+            <a:ext cx="5486400" cy="365760"/>
           </a:xfrm>
           <a:prstGeom prst="rect">
             <a:avLst/>
@@ -6776,7 +6776,7 @@
                   <a:srgbClr val="1A1A1A"/>
                 </a:solidFill>
               </a:rPr>
-              <a:t>Limits</a:t>
+              <a:t>Limits that come with the data</a:t>
             </a:r>
             <a:endParaRPr lang="en-US" sz="2000" dirty="0"/>
           </a:p>
@@ -6791,7 +6791,7 @@
         <p:spPr>
           <a:xfrm>
             <a:off x="548640" y="1828800"/>
-            <a:ext cx="5303520" cy="4297680"/>
+            <a:ext cx="5486400" cy="4389120"/>
           </a:xfrm>
           <a:prstGeom prst="rect">
             <a:avLst/>
@@ -6811,14 +6811,14 @@
               <a:buChar char="•"/>
             </a:pPr>
             <a:r>
-              <a:rPr lang="en-US" sz="1600" dirty="0">
+              <a:rPr lang="en-US" sz="1500" dirty="0">
                 <a:solidFill>
                   <a:srgbClr val="1A1A1A"/>
                 </a:solidFill>
               </a:rPr>
-              <a:t>One GraphSAGE configuration and one chronological split.</a:t>
+              <a:t>Only 22.85% of transactions are labelled. The unknown class has no ground truth.</a:t>
             </a:r>
-            <a:endParaRPr lang="en-US" sz="1600" dirty="0"/>
+            <a:endParaRPr lang="en-US" sz="1500" dirty="0"/>
           </a:p>
           <a:p>
             <a:pPr marL="342900" indent="-342900">
@@ -6829,14 +6829,14 @@
               <a:buChar char="•"/>
             </a:pPr>
             <a:r>
-              <a:rPr lang="en-US" sz="1600" dirty="0">
+              <a:rPr lang="en-US" sz="1500" dirty="0">
                 <a:solidFill>
                   <a:srgbClr val="1A1A1A"/>
                 </a:solidFill>
               </a:rPr>
-              <a:t>Illicit prevalence falls from 11.58% to 4.61%.</a:t>
+              <a:t>Illicit prevalence falls from 11.58% to 4.61%. The shift belongs to the dataset.</a:t>
             </a:r>
-            <a:endParaRPr lang="en-US" sz="1600" dirty="0"/>
+            <a:endParaRPr lang="en-US" sz="1500" dirty="0"/>
           </a:p>
           <a:p>
             <a:pPr marL="342900" indent="-342900">
@@ -6847,14 +6847,14 @@
               <a:buChar char="•"/>
             </a:pPr>
             <a:r>
-              <a:rPr lang="en-US" sz="1600" dirty="0">
+              <a:rPr lang="en-US" sz="1500" dirty="0">
                 <a:solidFill>
                   <a:srgbClr val="1A1A1A"/>
                 </a:solidFill>
               </a:rPr>
-              <a:t>Random Forest is stronger and has not seen feature set B.</a:t>
+              <a:t>Edges join transactions of the same time step, so order inside a step is lost.</a:t>
             </a:r>
-            <a:endParaRPr lang="en-US" sz="1600" dirty="0"/>
+            <a:endParaRPr lang="en-US" sz="1500" dirty="0"/>
           </a:p>
           <a:p>
             <a:pPr marL="342900" indent="-342900">
@@ -6865,14 +6865,14 @@
               <a:buChar char="•"/>
             </a:pPr>
             <a:r>
-              <a:rPr lang="en-US" sz="1600" dirty="0">
+              <a:rPr lang="en-US" sz="1500" dirty="0">
                 <a:solidFill>
                   <a:srgbClr val="1A1A1A"/>
                 </a:solidFill>
               </a:rPr>
-              <a:t>Most inherited features have no verified meaning.</a:t>
+              <a:t>147 of 166 inherited features have no verified meaning.</a:t>
             </a:r>
-            <a:endParaRPr lang="en-US" sz="1600" dirty="0"/>
+            <a:endParaRPr lang="en-US" sz="1500" dirty="0"/>
           </a:p>
           <a:p>
             <a:pPr marL="342900" indent="-342900">
@@ -6883,14 +6883,14 @@
               <a:buChar char="•"/>
             </a:pPr>
             <a:r>
-              <a:rPr lang="en-US" sz="1600" dirty="0">
+              <a:rPr lang="en-US" sz="1500" dirty="0">
                 <a:solidFill>
                   <a:srgbClr val="1A1A1A"/>
                 </a:solidFill>
               </a:rPr>
-              <a:t>Ablations are associations because the families overlap.</a:t>
+              <a:t>965 transactions have no address records.</a:t>
             </a:r>
-            <a:endParaRPr lang="en-US" sz="1600" dirty="0"/>
+            <a:endParaRPr lang="en-US" sz="1500" dirty="0"/>
           </a:p>
           <a:p>
             <a:pPr marL="342900" indent="-342900">
@@ -6901,14 +6901,32 @@
               <a:buChar char="•"/>
             </a:pPr>
             <a:r>
-              <a:rPr lang="en-US" sz="1600" dirty="0">
+              <a:rPr lang="en-US" sz="1500" dirty="0">
                 <a:solidFill>
                   <a:srgbClr val="1A1A1A"/>
                 </a:solidFill>
               </a:rPr>
-              <a:t>The unknown class has no ground truth.</a:t>
+              <a:t>No per-address BTC values exist, so value-based features cannot be rebuilt.</a:t>
             </a:r>
-            <a:endParaRPr lang="en-US" sz="1600" dirty="0"/>
+            <a:endParaRPr lang="en-US" sz="1500" dirty="0"/>
+          </a:p>
+          <a:p>
+            <a:pPr marL="342900" indent="-342900">
+              <a:spcAft>
+                <a:spcPts val="800"/>
+              </a:spcAft>
+              <a:buSzPct val="100000"/>
+              <a:buChar char="•"/>
+            </a:pPr>
+            <a:r>
+              <a:rPr lang="en-US" sz="1500" dirty="0">
+                <a:solidFill>
+                  <a:srgbClr val="1A1A1A"/>
+                </a:solidFill>
+              </a:rPr>
+              <a:t>The 13 audited features are a concern, not proven leakage.</a:t>
+            </a:r>
+            <a:endParaRPr lang="en-US" sz="1500" dirty="0"/>
           </a:p>
         </p:txBody>
       </p:sp>
@@ -6942,7 +6960,7 @@
                   <a:srgbClr val="1A1A1A"/>
                 </a:solidFill>
               </a:rPr>
-              <a:t>Next</a:t>
+              <a:t>Limits that come with the method</a:t>
             </a:r>
             <a:endParaRPr lang="en-US" sz="2000" dirty="0"/>
           </a:p>
@@ -6957,7 +6975,7 @@
         <p:spPr>
           <a:xfrm>
             <a:off x="6309360" y="1828800"/>
-            <a:ext cx="5303520" cy="4297680"/>
+            <a:ext cx="5303520" cy="4389120"/>
           </a:xfrm>
           <a:prstGeom prst="rect">
             <a:avLst/>
@@ -6977,14 +6995,14 @@
               <a:buChar char="•"/>
             </a:pPr>
             <a:r>
-              <a:rPr lang="en-US" sz="1600" dirty="0">
+              <a:rPr lang="en-US" sz="1500" dirty="0">
                 <a:solidFill>
                   <a:srgbClr val="1A1A1A"/>
                 </a:solidFill>
               </a:rPr>
-              <a:t>Train Random Forest and boosting on feature set B.</a:t>
+              <a:t>One GraphSAGE configuration and one chronological split.</a:t>
             </a:r>
-            <a:endParaRPr lang="en-US" sz="1600" dirty="0"/>
+            <a:endParaRPr lang="en-US" sz="1500" dirty="0"/>
           </a:p>
           <a:p>
             <a:pPr marL="342900" indent="-342900">
@@ -6995,14 +7013,14 @@
               <a:buChar char="•"/>
             </a:pPr>
             <a:r>
-              <a:rPr lang="en-US" sz="1600" dirty="0">
+              <a:rPr lang="en-US" sz="1500" dirty="0">
                 <a:solidFill>
                   <a:srgbClr val="1A1A1A"/>
                 </a:solidFill>
               </a:rPr>
-              <a:t>Evaluate on several time boundaries.</a:t>
+              <a:t>Random Forest, on the 184-feature set, is stronger on precision, F1 and PR-AUC.</a:t>
             </a:r>
-            <a:endParaRPr lang="en-US" sz="1600" dirty="0"/>
+            <a:endParaRPr lang="en-US" sz="1500" dirty="0"/>
           </a:p>
           <a:p>
             <a:pPr marL="342900" indent="-342900">
@@ -7013,14 +7031,14 @@
               <a:buChar char="•"/>
             </a:pPr>
             <a:r>
-              <a:rPr lang="en-US" sz="1600" dirty="0">
+              <a:rPr lang="en-US" sz="1500" dirty="0">
                 <a:solidFill>
                   <a:srgbClr val="1A1A1A"/>
                 </a:solidFill>
               </a:rPr>
-              <a:t>Report precision among the top k flagged transactions.</a:t>
+              <a:t>Ablations are associations because the feature families overlap.</a:t>
             </a:r>
-            <a:endParaRPr lang="en-US" sz="1600" dirty="0"/>
+            <a:endParaRPr lang="en-US" sz="1500" dirty="0"/>
           </a:p>
           <a:p>
             <a:pPr marL="342900" indent="-342900">
@@ -7031,14 +7049,14 @@
               <a:buChar char="•"/>
             </a:pPr>
             <a:r>
-              <a:rPr lang="en-US" sz="1600" dirty="0">
+              <a:rPr lang="en-US" sz="1500" dirty="0">
                 <a:solidFill>
                   <a:srgbClr val="1A1A1A"/>
                 </a:solidFill>
               </a:rPr>
-              <a:t>Test the fingerprint rule alone on the test split.</a:t>
+              <a:t>Attribution measures model sensitivity, not cause.</a:t>
             </a:r>
-            <a:endParaRPr lang="en-US" sz="1600" dirty="0"/>
+            <a:endParaRPr lang="en-US" sz="1500" dirty="0"/>
           </a:p>
           <a:p>
             <a:pPr marL="342900" indent="-342900">
@@ -7049,14 +7067,14 @@
               <a:buChar char="•"/>
             </a:pPr>
             <a:r>
-              <a:rPr lang="en-US" sz="1600" dirty="0">
+              <a:rPr lang="en-US" sz="1500" dirty="0">
                 <a:solidFill>
                   <a:srgbClr val="1A1A1A"/>
                 </a:solidFill>
               </a:rPr>
-              <a:t>Run ten seeds and repeat attribution with other baselines.</a:t>
+              <a:t>579 scores print as 1.000000, so ranking uses logit margins.</a:t>
             </a:r>
-            <a:endParaRPr lang="en-US" sz="1600" dirty="0"/>
+            <a:endParaRPr lang="en-US" sz="1500" dirty="0"/>
           </a:p>
           <a:p>
             <a:pPr marL="342900" indent="-342900">
@@ -7067,14 +7085,14 @@
               <a:buChar char="•"/>
             </a:pPr>
             <a:r>
-              <a:rPr lang="en-US" sz="1600" dirty="0">
+              <a:rPr lang="en-US" sz="1500" dirty="0">
                 <a:solidFill>
                   <a:srgbClr val="1A1A1A"/>
                 </a:solidFill>
               </a:rPr>
-              <a:t>Audit the 150 inherited features not yet examined.</a:t>
+              <a:t>A high score does not establish illicit activity.</a:t>
             </a:r>
-            <a:endParaRPr lang="en-US" sz="1600" dirty="0"/>
+            <a:endParaRPr lang="en-US" sz="1500" dirty="0"/>
           </a:p>
         </p:txBody>
       </p:sp>

</xml_diff>